<commit_message>
Expand Stores and Admin PPTX decks with substantive content
06-stores-user:
- New meta row explaining GRNs close the loop on approved PRs
- New 'Where You Fit in the Full Supply Chain' workflow slide showing
  the complete path from PR submission through to goods issued
- GRN task slide now includes a note on always linking to the correct PR
- New 'Common Pitfalls & Checklist' slide covering pre-GRN, pre-Issue
  Slip checks and the most common mistakes

07-admin:
- New meta row noting Admin can see all views including Incoming PRs
- 'Who You Are' updated to list Incoming PRs visibility explicitly
- New 'Role Capabilities' two-col slide — reference for what each role
  unlocks when creating users (including Procurement's Incoming PRs
  access and the Stores flag)
- 'Create a User' step updated to note Procurement role gives Incoming
  PRs and vendor management automatically

Co-Authored-By: Claude Sonnet 4.6 <noreply@anthropic.com>
</commit_message>
<xml_diff>
--- a/docs/user-manual/06-stores-user.pptx
+++ b/docs/user-manual/06-stores-user.pptx
@@ -12,6 +12,8 @@
     <p:sldId id="260" r:id="rId11"/>
     <p:sldId id="261" r:id="rId12"/>
     <p:sldId id="262" r:id="rId13"/>
+    <p:sldId id="263" r:id="rId14"/>
+    <p:sldId id="264" r:id="rId15"/>
   </p:sldIdLst>
   <p:sldSz cx="12188952" cy="6858000" type="screen4x3"/>
   <p:notesSz cx="6858000" cy="9144000"/>
@@ -3503,6 +3505,48 @@
           </a:p>
         </p:txBody>
       </p:sp>
+      <p:sp>
+        <p:nvSpPr>
+          <p:cNvPr id="12" name="TextBox 11"/>
+          <p:cNvSpPr txBox="1"/>
+          <p:nvPr/>
+        </p:nvSpPr>
+        <p:spPr>
+          <a:xfrm>
+            <a:off x="2926080" y="4992624"/>
+            <a:ext cx="6400800" cy="292608"/>
+          </a:xfrm>
+          <a:prstGeom prst="rect">
+            <a:avLst/>
+          </a:prstGeom>
+          <a:noFill/>
+        </p:spPr>
+        <p:txBody>
+          <a:bodyPr wrap="none">
+            <a:spAutoFit/>
+          </a:bodyPr>
+          <a:lstStyle/>
+          <a:p>
+            <a:pPr algn="l"/>
+            <a:r>
+              <a:rPr sz="1100" b="1">
+                <a:solidFill>
+                  <a:srgbClr val="8AB4D8"/>
+                </a:solidFill>
+              </a:rPr>
+              <a:t>Key link:  </a:t>
+            </a:r>
+            <a:r>
+              <a:rPr sz="1100">
+                <a:solidFill>
+                  <a:srgbClr val="D0E3F2"/>
+                </a:solidFill>
+              </a:rPr>
+              <a:t>Your GRN closes the loop on every approved Purchase Requisition</a:t>
+            </a:r>
+          </a:p>
+        </p:txBody>
+      </p:sp>
     </p:spTree>
   </p:cSld>
   <p:clrMapOvr>
@@ -3930,7 +3974,7 @@
                   <a:srgbClr val="111111"/>
                 </a:solidFill>
               </a:rPr>
-              <a:t>Match deliveries to the correct PR</a:t>
+              <a:t>Always link a GRN to the correct approved PR</a:t>
             </a:r>
           </a:p>
           <a:p>
@@ -3961,6 +4005,21 @@
                 </a:solidFill>
               </a:rPr>
               <a:t>Keep the Stock Items list free of duplicates</a:t>
+            </a:r>
+          </a:p>
+          <a:p>
+            <a:pPr>
+              <a:spcBef>
+                <a:spcPts val="300"/>
+              </a:spcBef>
+            </a:pPr>
+            <a:r>
+              <a:rPr sz="1300">
+                <a:solidFill>
+                  <a:srgbClr val="111111"/>
+                </a:solidFill>
+              </a:rPr>
+              <a:t>Notify Finance promptly when a GRN is created so they can approve without delay</a:t>
             </a:r>
           </a:p>
         </p:txBody>
@@ -4055,7 +4114,7 @@
                   <a:srgbClr val="FFFFFF"/>
                 </a:solidFill>
               </a:rPr>
-              <a:t>Stores Workflow Diagrams</a:t>
+              <a:t>Where You Fit in the Full Supply Chain</a:t>
             </a:r>
           </a:p>
         </p:txBody>
@@ -4132,7 +4191,7 @@
                 </a:solidFill>
                 <a:latin typeface="Consolas"/>
               </a:rPr>
-              <a:t>GOODS IN (GRN):</a:t>
+              <a:t>  [Dept submits PR] --&gt; HOD approves --&gt; Finance approves --&gt; MD approves (if high value)</a:t>
             </a:r>
           </a:p>
           <a:p>
@@ -4143,7 +4202,7 @@
                 </a:solidFill>
                 <a:latin typeface="Consolas"/>
               </a:rPr>
-              <a:t>  [Supplier delivers] --&gt; [You create GRN] --&gt; pending_approval</a:t>
+              <a:t>                                                                      |</a:t>
             </a:r>
           </a:p>
           <a:p>
@@ -4154,7 +4213,7 @@
                 </a:solidFill>
                 <a:latin typeface="Consolas"/>
               </a:rPr>
-              <a:t>                                                      |</a:t>
+              <a:t>                                                                  approved</a:t>
             </a:r>
           </a:p>
           <a:p>
@@ -4165,7 +4224,7 @@
                 </a:solidFill>
                 <a:latin typeface="Consolas"/>
               </a:rPr>
-              <a:t>                                            Finance approves / rejects</a:t>
+              <a:t>                                                                      |</a:t>
             </a:r>
           </a:p>
           <a:p>
@@ -4176,7 +4235,7 @@
                 </a:solidFill>
                 <a:latin typeface="Consolas"/>
               </a:rPr>
-              <a:t>                                                      v</a:t>
+              <a:t>                                                   Procurement raises PO with the vendor</a:t>
             </a:r>
           </a:p>
           <a:p>
@@ -4187,7 +4246,7 @@
                 </a:solidFill>
                 <a:latin typeface="Consolas"/>
               </a:rPr>
-              <a:t>                                                  approved</a:t>
+              <a:t>                                                                      |</a:t>
             </a:r>
           </a:p>
           <a:p>
@@ -4198,7 +4257,7 @@
                 </a:solidFill>
                 <a:latin typeface="Consolas"/>
               </a:rPr>
-              <a:t>                                           (stock is now in register)</a:t>
+              <a:t>                                                          Supplier delivers goods</a:t>
             </a:r>
           </a:p>
           <a:p>
@@ -4209,7 +4268,7 @@
                 </a:solidFill>
                 <a:latin typeface="Consolas"/>
               </a:rPr>
-              <a:t/>
+              <a:t>                                                                      |</a:t>
             </a:r>
           </a:p>
           <a:p>
@@ -4220,7 +4279,7 @@
                 </a:solidFill>
                 <a:latin typeface="Consolas"/>
               </a:rPr>
-              <a:t>GOODS OUT (Issue Slip):</a:t>
+              <a:t>                                                    YOU create a GRN linked to the PR</a:t>
             </a:r>
           </a:p>
           <a:p>
@@ -4231,7 +4290,7 @@
                 </a:solidFill>
                 <a:latin typeface="Consolas"/>
               </a:rPr>
-              <a:t>  [You create Issue Slip] --&gt; pending_hod --&gt; pending_finance --&gt; approved</a:t>
+              <a:t>                                                                      |</a:t>
             </a:r>
           </a:p>
           <a:p>
@@ -4242,7 +4301,7 @@
                 </a:solidFill>
                 <a:latin typeface="Consolas"/>
               </a:rPr>
-              <a:t>                                                                     |</a:t>
+              <a:t>                                                         Finance approves the GRN</a:t>
             </a:r>
           </a:p>
           <a:p>
@@ -4253,7 +4312,7 @@
                 </a:solidFill>
                 <a:latin typeface="Consolas"/>
               </a:rPr>
-              <a:t>                                               stock officially deducted from register</a:t>
+              <a:t>                                                                      |</a:t>
             </a:r>
           </a:p>
           <a:p>
@@ -4264,7 +4323,7 @@
                 </a:solidFill>
                 <a:latin typeface="Consolas"/>
               </a:rPr>
-              <a:t/>
+              <a:t>                                                    Stock is available in the register</a:t>
             </a:r>
           </a:p>
           <a:p>
@@ -4275,7 +4334,7 @@
                 </a:solidFill>
                 <a:latin typeface="Consolas"/>
               </a:rPr>
-              <a:t>STOCK MOVE (Picking Slip):</a:t>
+              <a:t>                                                                      |</a:t>
             </a:r>
           </a:p>
           <a:p>
@@ -4286,7 +4345,7 @@
                 </a:solidFill>
                 <a:latin typeface="Consolas"/>
               </a:rPr>
-              <a:t>  [You create Picking Slip] --&gt; completed immediately (no approval needed)</a:t>
+              <a:t>                                          YOU create Issue Slip → goods leave to dept</a:t>
             </a:r>
           </a:p>
         </p:txBody>
@@ -4381,27 +4440,27 @@
                   <a:srgbClr val="FFFFFF"/>
                 </a:solidFill>
               </a:rPr>
-              <a:t>Task: Create a Goods Receipt Note (GRN)</a:t>
-            </a:r>
-          </a:p>
-        </p:txBody>
-      </p:sp>
-      <p:sp>
-        <p:nvSpPr>
-          <p:cNvPr id="4" name="Oval 3"/>
+              <a:t>Stores Document Workflows</a:t>
+            </a:r>
+          </a:p>
+        </p:txBody>
+      </p:sp>
+      <p:sp>
+        <p:nvSpPr>
+          <p:cNvPr id="4" name="Rectangle 3"/>
           <p:cNvSpPr/>
           <p:nvPr/>
         </p:nvSpPr>
         <p:spPr>
           <a:xfrm>
-            <a:off x="502920" y="1243584"/>
-            <a:ext cx="411480" cy="411480"/>
-          </a:xfrm>
-          <a:prstGeom prst="ellipse">
+            <a:off x="502920" y="1188720"/>
+            <a:ext cx="11183112" cy="5349240"/>
+          </a:xfrm>
+          <a:prstGeom prst="rect">
             <a:avLst/>
           </a:prstGeom>
           <a:solidFill>
-            <a:srgbClr val="0B4A8A"/>
+            <a:srgbClr val="EAF2FB"/>
           </a:solidFill>
           <a:ln>
             <a:noFill/>
@@ -4426,14 +4485,6 @@
           <a:lstStyle/>
           <a:p>
             <a:pPr algn="ctr"/>
-            <a:r>
-              <a:rPr sz="1200" b="1">
-                <a:solidFill>
-                  <a:srgbClr val="FFFFFF"/>
-                </a:solidFill>
-              </a:rPr>
-              <a:t>1</a:t>
-            </a:r>
           </a:p>
         </p:txBody>
       </p:sp>
@@ -4445,8 +4496,8 @@
         </p:nvSpPr>
         <p:spPr>
           <a:xfrm>
-            <a:off x="1033272" y="1188720"/>
-            <a:ext cx="10634472" cy="566928"/>
+            <a:off x="777240" y="1371600"/>
+            <a:ext cx="10634472" cy="4983480"/>
           </a:xfrm>
           <a:prstGeom prst="rect">
             <a:avLst/>
@@ -4454,529 +4505,173 @@
           <a:noFill/>
         </p:spPr>
         <p:txBody>
-          <a:bodyPr wrap="square">
+          <a:bodyPr wrap="none">
             <a:spAutoFit/>
           </a:bodyPr>
           <a:lstStyle/>
           <a:p>
-            <a:pPr algn="l"/>
-            <a:r>
-              <a:rPr sz="1300" b="0" i="0">
-                <a:solidFill>
-                  <a:srgbClr val="111111"/>
-                </a:solidFill>
-              </a:rPr>
-              <a:t>Sidebar → Stores → Create GRN.</a:t>
-            </a:r>
-          </a:p>
-        </p:txBody>
-      </p:sp>
-      <p:sp>
-        <p:nvSpPr>
-          <p:cNvPr id="6" name="Oval 5"/>
-          <p:cNvSpPr/>
-          <p:nvPr/>
-        </p:nvSpPr>
-        <p:spPr>
-          <a:xfrm>
-            <a:off x="502920" y="1810512"/>
-            <a:ext cx="411480" cy="411480"/>
-          </a:xfrm>
-          <a:prstGeom prst="ellipse">
-            <a:avLst/>
-          </a:prstGeom>
-          <a:solidFill>
-            <a:srgbClr val="0B4A8A"/>
-          </a:solidFill>
-          <a:ln>
-            <a:noFill/>
-          </a:ln>
-        </p:spPr>
-        <p:style>
-          <a:lnRef idx="1">
-            <a:schemeClr val="accent1"/>
-          </a:lnRef>
-          <a:fillRef idx="3">
-            <a:schemeClr val="accent1"/>
-          </a:fillRef>
-          <a:effectRef idx="2">
-            <a:schemeClr val="accent1"/>
-          </a:effectRef>
-          <a:fontRef idx="minor">
-            <a:schemeClr val="lt1"/>
-          </a:fontRef>
-        </p:style>
-        <p:txBody>
-          <a:bodyPr rtlCol="0" anchor="ctr"/>
-          <a:lstStyle/>
-          <a:p>
-            <a:pPr algn="ctr"/>
-            <a:r>
-              <a:rPr sz="1200" b="1">
-                <a:solidFill>
-                  <a:srgbClr val="FFFFFF"/>
-                </a:solidFill>
-              </a:rPr>
-              <a:t>2</a:t>
-            </a:r>
-          </a:p>
-        </p:txBody>
-      </p:sp>
-      <p:sp>
-        <p:nvSpPr>
-          <p:cNvPr id="7" name="TextBox 6"/>
-          <p:cNvSpPr txBox="1"/>
-          <p:nvPr/>
-        </p:nvSpPr>
-        <p:spPr>
-          <a:xfrm>
-            <a:off x="1033272" y="1755648"/>
-            <a:ext cx="10634472" cy="566928"/>
-          </a:xfrm>
-          <a:prstGeom prst="rect">
-            <a:avLst/>
-          </a:prstGeom>
-          <a:noFill/>
-        </p:spPr>
-        <p:txBody>
-          <a:bodyPr wrap="square">
-            <a:spAutoFit/>
-          </a:bodyPr>
-          <a:lstStyle/>
-          <a:p>
-            <a:pPr algn="l"/>
-            <a:r>
-              <a:rPr sz="1300" b="0" i="0">
-                <a:solidFill>
-                  <a:srgbClr val="111111"/>
-                </a:solidFill>
-              </a:rPr>
-              <a:t>Fill the header: GRN Date, Supplier/Vendor, Reference PR (the approved PR this delivery fulfils).</a:t>
-            </a:r>
-          </a:p>
-        </p:txBody>
-      </p:sp>
-      <p:sp>
-        <p:nvSpPr>
-          <p:cNvPr id="8" name="Oval 7"/>
-          <p:cNvSpPr/>
-          <p:nvPr/>
-        </p:nvSpPr>
-        <p:spPr>
-          <a:xfrm>
-            <a:off x="502920" y="2377440"/>
-            <a:ext cx="411480" cy="411480"/>
-          </a:xfrm>
-          <a:prstGeom prst="ellipse">
-            <a:avLst/>
-          </a:prstGeom>
-          <a:solidFill>
-            <a:srgbClr val="0B4A8A"/>
-          </a:solidFill>
-          <a:ln>
-            <a:noFill/>
-          </a:ln>
-        </p:spPr>
-        <p:style>
-          <a:lnRef idx="1">
-            <a:schemeClr val="accent1"/>
-          </a:lnRef>
-          <a:fillRef idx="3">
-            <a:schemeClr val="accent1"/>
-          </a:fillRef>
-          <a:effectRef idx="2">
-            <a:schemeClr val="accent1"/>
-          </a:effectRef>
-          <a:fontRef idx="minor">
-            <a:schemeClr val="lt1"/>
-          </a:fontRef>
-        </p:style>
-        <p:txBody>
-          <a:bodyPr rtlCol="0" anchor="ctr"/>
-          <a:lstStyle/>
-          <a:p>
-            <a:pPr algn="ctr"/>
-            <a:r>
-              <a:rPr sz="1200" b="1">
-                <a:solidFill>
-                  <a:srgbClr val="FFFFFF"/>
-                </a:solidFill>
-              </a:rPr>
-              <a:t>3</a:t>
-            </a:r>
-          </a:p>
-        </p:txBody>
-      </p:sp>
-      <p:sp>
-        <p:nvSpPr>
-          <p:cNvPr id="9" name="TextBox 8"/>
-          <p:cNvSpPr txBox="1"/>
-          <p:nvPr/>
-        </p:nvSpPr>
-        <p:spPr>
-          <a:xfrm>
-            <a:off x="1033272" y="2322576"/>
-            <a:ext cx="10634472" cy="566928"/>
-          </a:xfrm>
-          <a:prstGeom prst="rect">
-            <a:avLst/>
-          </a:prstGeom>
-          <a:noFill/>
-        </p:spPr>
-        <p:txBody>
-          <a:bodyPr wrap="square">
-            <a:spAutoFit/>
-          </a:bodyPr>
-          <a:lstStyle/>
-          <a:p>
-            <a:pPr algn="l"/>
-            <a:r>
-              <a:rPr sz="1300" b="0" i="0">
-                <a:solidFill>
-                  <a:srgbClr val="111111"/>
-                </a:solidFill>
-              </a:rPr>
-              <a:t>Add each item received: select stock item, enter quantity received, unit, and condition.</a:t>
-            </a:r>
-          </a:p>
-        </p:txBody>
-      </p:sp>
-      <p:sp>
-        <p:nvSpPr>
-          <p:cNvPr id="10" name="Oval 9"/>
-          <p:cNvSpPr/>
-          <p:nvPr/>
-        </p:nvSpPr>
-        <p:spPr>
-          <a:xfrm>
-            <a:off x="502920" y="2944368"/>
-            <a:ext cx="411480" cy="411480"/>
-          </a:xfrm>
-          <a:prstGeom prst="ellipse">
-            <a:avLst/>
-          </a:prstGeom>
-          <a:solidFill>
-            <a:srgbClr val="0B4A8A"/>
-          </a:solidFill>
-          <a:ln>
-            <a:noFill/>
-          </a:ln>
-        </p:spPr>
-        <p:style>
-          <a:lnRef idx="1">
-            <a:schemeClr val="accent1"/>
-          </a:lnRef>
-          <a:fillRef idx="3">
-            <a:schemeClr val="accent1"/>
-          </a:fillRef>
-          <a:effectRef idx="2">
-            <a:schemeClr val="accent1"/>
-          </a:effectRef>
-          <a:fontRef idx="minor">
-            <a:schemeClr val="lt1"/>
-          </a:fontRef>
-        </p:style>
-        <p:txBody>
-          <a:bodyPr rtlCol="0" anchor="ctr"/>
-          <a:lstStyle/>
-          <a:p>
-            <a:pPr algn="ctr"/>
-            <a:r>
-              <a:rPr sz="1200" b="1">
-                <a:solidFill>
-                  <a:srgbClr val="FFFFFF"/>
-                </a:solidFill>
-              </a:rPr>
-              <a:t>4</a:t>
-            </a:r>
-          </a:p>
-        </p:txBody>
-      </p:sp>
-      <p:sp>
-        <p:nvSpPr>
-          <p:cNvPr id="11" name="TextBox 10"/>
-          <p:cNvSpPr txBox="1"/>
-          <p:nvPr/>
-        </p:nvSpPr>
-        <p:spPr>
-          <a:xfrm>
-            <a:off x="1033272" y="2889504"/>
-            <a:ext cx="10634472" cy="566928"/>
-          </a:xfrm>
-          <a:prstGeom prst="rect">
-            <a:avLst/>
-          </a:prstGeom>
-          <a:noFill/>
-        </p:spPr>
-        <p:txBody>
-          <a:bodyPr wrap="square">
-            <a:spAutoFit/>
-          </a:bodyPr>
-          <a:lstStyle/>
-          <a:p>
-            <a:pPr algn="l"/>
-            <a:r>
-              <a:rPr sz="1300" b="0" i="0">
-                <a:solidFill>
-                  <a:srgbClr val="111111"/>
-                </a:solidFill>
-              </a:rPr>
-              <a:t>If the GRN is for a specific customer, set the Customer field.</a:t>
-            </a:r>
-          </a:p>
-        </p:txBody>
-      </p:sp>
-      <p:sp>
-        <p:nvSpPr>
-          <p:cNvPr id="12" name="Oval 11"/>
-          <p:cNvSpPr/>
-          <p:nvPr/>
-        </p:nvSpPr>
-        <p:spPr>
-          <a:xfrm>
-            <a:off x="502920" y="3511296"/>
-            <a:ext cx="411480" cy="411480"/>
-          </a:xfrm>
-          <a:prstGeom prst="ellipse">
-            <a:avLst/>
-          </a:prstGeom>
-          <a:solidFill>
-            <a:srgbClr val="0B4A8A"/>
-          </a:solidFill>
-          <a:ln>
-            <a:noFill/>
-          </a:ln>
-        </p:spPr>
-        <p:style>
-          <a:lnRef idx="1">
-            <a:schemeClr val="accent1"/>
-          </a:lnRef>
-          <a:fillRef idx="3">
-            <a:schemeClr val="accent1"/>
-          </a:fillRef>
-          <a:effectRef idx="2">
-            <a:schemeClr val="accent1"/>
-          </a:effectRef>
-          <a:fontRef idx="minor">
-            <a:schemeClr val="lt1"/>
-          </a:fontRef>
-        </p:style>
-        <p:txBody>
-          <a:bodyPr rtlCol="0" anchor="ctr"/>
-          <a:lstStyle/>
-          <a:p>
-            <a:pPr algn="ctr"/>
-            <a:r>
-              <a:rPr sz="1200" b="1">
-                <a:solidFill>
-                  <a:srgbClr val="FFFFFF"/>
-                </a:solidFill>
-              </a:rPr>
-              <a:t>5</a:t>
-            </a:r>
-          </a:p>
-        </p:txBody>
-      </p:sp>
-      <p:sp>
-        <p:nvSpPr>
-          <p:cNvPr id="13" name="TextBox 12"/>
-          <p:cNvSpPr txBox="1"/>
-          <p:nvPr/>
-        </p:nvSpPr>
-        <p:spPr>
-          <a:xfrm>
-            <a:off x="1033272" y="3456432"/>
-            <a:ext cx="10634472" cy="566928"/>
-          </a:xfrm>
-          <a:prstGeom prst="rect">
-            <a:avLst/>
-          </a:prstGeom>
-          <a:noFill/>
-        </p:spPr>
-        <p:txBody>
-          <a:bodyPr wrap="square">
-            <a:spAutoFit/>
-          </a:bodyPr>
-          <a:lstStyle/>
-          <a:p>
-            <a:pPr algn="l"/>
-            <a:r>
-              <a:rPr sz="1300" b="0" i="0">
-                <a:solidFill>
-                  <a:srgbClr val="111111"/>
-                </a:solidFill>
-              </a:rPr>
-              <a:t>Attach the supplier delivery note or invoice.</a:t>
-            </a:r>
-          </a:p>
-        </p:txBody>
-      </p:sp>
-      <p:sp>
-        <p:nvSpPr>
-          <p:cNvPr id="14" name="Oval 13"/>
-          <p:cNvSpPr/>
-          <p:nvPr/>
-        </p:nvSpPr>
-        <p:spPr>
-          <a:xfrm>
-            <a:off x="502920" y="4078224"/>
-            <a:ext cx="411480" cy="411480"/>
-          </a:xfrm>
-          <a:prstGeom prst="ellipse">
-            <a:avLst/>
-          </a:prstGeom>
-          <a:solidFill>
-            <a:srgbClr val="0B4A8A"/>
-          </a:solidFill>
-          <a:ln>
-            <a:noFill/>
-          </a:ln>
-        </p:spPr>
-        <p:style>
-          <a:lnRef idx="1">
-            <a:schemeClr val="accent1"/>
-          </a:lnRef>
-          <a:fillRef idx="3">
-            <a:schemeClr val="accent1"/>
-          </a:fillRef>
-          <a:effectRef idx="2">
-            <a:schemeClr val="accent1"/>
-          </a:effectRef>
-          <a:fontRef idx="minor">
-            <a:schemeClr val="lt1"/>
-          </a:fontRef>
-        </p:style>
-        <p:txBody>
-          <a:bodyPr rtlCol="0" anchor="ctr"/>
-          <a:lstStyle/>
-          <a:p>
-            <a:pPr algn="ctr"/>
-            <a:r>
-              <a:rPr sz="1200" b="1">
-                <a:solidFill>
-                  <a:srgbClr val="FFFFFF"/>
-                </a:solidFill>
-              </a:rPr>
-              <a:t>6</a:t>
-            </a:r>
-          </a:p>
-        </p:txBody>
-      </p:sp>
-      <p:sp>
-        <p:nvSpPr>
-          <p:cNvPr id="15" name="TextBox 14"/>
-          <p:cNvSpPr txBox="1"/>
-          <p:nvPr/>
-        </p:nvSpPr>
-        <p:spPr>
-          <a:xfrm>
-            <a:off x="1033272" y="4023360"/>
-            <a:ext cx="10634472" cy="566928"/>
-          </a:xfrm>
-          <a:prstGeom prst="rect">
-            <a:avLst/>
-          </a:prstGeom>
-          <a:noFill/>
-        </p:spPr>
-        <p:txBody>
-          <a:bodyPr wrap="square">
-            <a:spAutoFit/>
-          </a:bodyPr>
-          <a:lstStyle/>
-          <a:p>
-            <a:pPr algn="l"/>
-            <a:r>
-              <a:rPr sz="1300" b="0" i="0">
-                <a:solidFill>
-                  <a:srgbClr val="111111"/>
-                </a:solidFill>
-              </a:rPr>
-              <a:t>Click Submit. Status becomes pending_approval. Finance will review and approve.</a:t>
-            </a:r>
-          </a:p>
-        </p:txBody>
-      </p:sp>
-      <p:sp>
-        <p:nvSpPr>
-          <p:cNvPr id="16" name="Oval 15"/>
-          <p:cNvSpPr/>
-          <p:nvPr/>
-        </p:nvSpPr>
-        <p:spPr>
-          <a:xfrm>
-            <a:off x="502920" y="4645152"/>
-            <a:ext cx="411480" cy="411480"/>
-          </a:xfrm>
-          <a:prstGeom prst="ellipse">
-            <a:avLst/>
-          </a:prstGeom>
-          <a:solidFill>
-            <a:srgbClr val="0B4A8A"/>
-          </a:solidFill>
-          <a:ln>
-            <a:noFill/>
-          </a:ln>
-        </p:spPr>
-        <p:style>
-          <a:lnRef idx="1">
-            <a:schemeClr val="accent1"/>
-          </a:lnRef>
-          <a:fillRef idx="3">
-            <a:schemeClr val="accent1"/>
-          </a:fillRef>
-          <a:effectRef idx="2">
-            <a:schemeClr val="accent1"/>
-          </a:effectRef>
-          <a:fontRef idx="minor">
-            <a:schemeClr val="lt1"/>
-          </a:fontRef>
-        </p:style>
-        <p:txBody>
-          <a:bodyPr rtlCol="0" anchor="ctr"/>
-          <a:lstStyle/>
-          <a:p>
-            <a:pPr algn="ctr"/>
-            <a:r>
-              <a:rPr sz="1200" b="1">
-                <a:solidFill>
-                  <a:srgbClr val="FFFFFF"/>
-                </a:solidFill>
-              </a:rPr>
-              <a:t>7</a:t>
-            </a:r>
-          </a:p>
-        </p:txBody>
-      </p:sp>
-      <p:sp>
-        <p:nvSpPr>
-          <p:cNvPr id="17" name="TextBox 16"/>
-          <p:cNvSpPr txBox="1"/>
-          <p:nvPr/>
-        </p:nvSpPr>
-        <p:spPr>
-          <a:xfrm>
-            <a:off x="1033272" y="4590288"/>
-            <a:ext cx="10634472" cy="566928"/>
-          </a:xfrm>
-          <a:prstGeom prst="rect">
-            <a:avLst/>
-          </a:prstGeom>
-          <a:noFill/>
-        </p:spPr>
-        <p:txBody>
-          <a:bodyPr wrap="square">
-            <a:spAutoFit/>
-          </a:bodyPr>
-          <a:lstStyle/>
-          <a:p>
-            <a:pPr algn="l"/>
-            <a:r>
-              <a:rPr sz="1300" b="0" i="0">
-                <a:solidFill>
-                  <a:srgbClr val="111111"/>
-                </a:solidFill>
-              </a:rPr>
-              <a:t>Only after Finance approval can stock be drawn via Issue Slips.</a:t>
+            <a:r>
+              <a:rPr sz="1200">
+                <a:solidFill>
+                  <a:srgbClr val="111111"/>
+                </a:solidFill>
+                <a:latin typeface="Consolas"/>
+              </a:rPr>
+              <a:t>GOODS IN (GRN):</a:t>
+            </a:r>
+          </a:p>
+          <a:p>
+            <a:r>
+              <a:rPr sz="1200">
+                <a:solidFill>
+                  <a:srgbClr val="111111"/>
+                </a:solidFill>
+                <a:latin typeface="Consolas"/>
+              </a:rPr>
+              <a:t>  [Supplier delivers] --&gt; [You create GRN] --&gt; pending_approval</a:t>
+            </a:r>
+          </a:p>
+          <a:p>
+            <a:r>
+              <a:rPr sz="1200">
+                <a:solidFill>
+                  <a:srgbClr val="111111"/>
+                </a:solidFill>
+                <a:latin typeface="Consolas"/>
+              </a:rPr>
+              <a:t>                                                      |</a:t>
+            </a:r>
+          </a:p>
+          <a:p>
+            <a:r>
+              <a:rPr sz="1200">
+                <a:solidFill>
+                  <a:srgbClr val="111111"/>
+                </a:solidFill>
+                <a:latin typeface="Consolas"/>
+              </a:rPr>
+              <a:t>                                            Finance approves / rejects</a:t>
+            </a:r>
+          </a:p>
+          <a:p>
+            <a:r>
+              <a:rPr sz="1200">
+                <a:solidFill>
+                  <a:srgbClr val="111111"/>
+                </a:solidFill>
+                <a:latin typeface="Consolas"/>
+              </a:rPr>
+              <a:t>                                                      v</a:t>
+            </a:r>
+          </a:p>
+          <a:p>
+            <a:r>
+              <a:rPr sz="1200">
+                <a:solidFill>
+                  <a:srgbClr val="111111"/>
+                </a:solidFill>
+                <a:latin typeface="Consolas"/>
+              </a:rPr>
+              <a:t>                                                  approved</a:t>
+            </a:r>
+          </a:p>
+          <a:p>
+            <a:r>
+              <a:rPr sz="1200">
+                <a:solidFill>
+                  <a:srgbClr val="111111"/>
+                </a:solidFill>
+                <a:latin typeface="Consolas"/>
+              </a:rPr>
+              <a:t>                                           (stock is now in register)</a:t>
+            </a:r>
+          </a:p>
+          <a:p>
+            <a:r>
+              <a:rPr sz="1200">
+                <a:solidFill>
+                  <a:srgbClr val="111111"/>
+                </a:solidFill>
+                <a:latin typeface="Consolas"/>
+              </a:rPr>
+              <a:t/>
+            </a:r>
+          </a:p>
+          <a:p>
+            <a:r>
+              <a:rPr sz="1200">
+                <a:solidFill>
+                  <a:srgbClr val="111111"/>
+                </a:solidFill>
+                <a:latin typeface="Consolas"/>
+              </a:rPr>
+              <a:t>GOODS OUT (Issue Slip):</a:t>
+            </a:r>
+          </a:p>
+          <a:p>
+            <a:r>
+              <a:rPr sz="1200">
+                <a:solidFill>
+                  <a:srgbClr val="111111"/>
+                </a:solidFill>
+                <a:latin typeface="Consolas"/>
+              </a:rPr>
+              <a:t>  [You create Issue Slip] --&gt; pending_hod --&gt; pending_finance --&gt; approved</a:t>
+            </a:r>
+          </a:p>
+          <a:p>
+            <a:r>
+              <a:rPr sz="1200">
+                <a:solidFill>
+                  <a:srgbClr val="111111"/>
+                </a:solidFill>
+                <a:latin typeface="Consolas"/>
+              </a:rPr>
+              <a:t>                                                                     |</a:t>
+            </a:r>
+          </a:p>
+          <a:p>
+            <a:r>
+              <a:rPr sz="1200">
+                <a:solidFill>
+                  <a:srgbClr val="111111"/>
+                </a:solidFill>
+                <a:latin typeface="Consolas"/>
+              </a:rPr>
+              <a:t>                                               stock officially deducted from register</a:t>
+            </a:r>
+          </a:p>
+          <a:p>
+            <a:r>
+              <a:rPr sz="1200">
+                <a:solidFill>
+                  <a:srgbClr val="111111"/>
+                </a:solidFill>
+                <a:latin typeface="Consolas"/>
+              </a:rPr>
+              <a:t/>
+            </a:r>
+          </a:p>
+          <a:p>
+            <a:r>
+              <a:rPr sz="1200">
+                <a:solidFill>
+                  <a:srgbClr val="111111"/>
+                </a:solidFill>
+                <a:latin typeface="Consolas"/>
+              </a:rPr>
+              <a:t>STOCK MOVE (Picking Slip):</a:t>
+            </a:r>
+          </a:p>
+          <a:p>
+            <a:r>
+              <a:rPr sz="1200">
+                <a:solidFill>
+                  <a:srgbClr val="111111"/>
+                </a:solidFill>
+                <a:latin typeface="Consolas"/>
+              </a:rPr>
+              <a:t>  [You create Picking Slip] --&gt; completed immediately (no approval needed)</a:t>
             </a:r>
           </a:p>
         </p:txBody>
@@ -5071,20 +4766,54 @@
                   <a:srgbClr val="FFFFFF"/>
                 </a:solidFill>
               </a:rPr>
-              <a:t>Task: Create an Issue Slip</a:t>
-            </a:r>
-          </a:p>
-        </p:txBody>
-      </p:sp>
-      <p:sp>
-        <p:nvSpPr>
-          <p:cNvPr id="4" name="Oval 3"/>
+              <a:t>Task: Create a Goods Receipt Note (GRN)</a:t>
+            </a:r>
+          </a:p>
+        </p:txBody>
+      </p:sp>
+      <p:sp>
+        <p:nvSpPr>
+          <p:cNvPr id="4" name="TextBox 3"/>
+          <p:cNvSpPr txBox="1"/>
+          <p:nvPr/>
+        </p:nvSpPr>
+        <p:spPr>
+          <a:xfrm>
+            <a:off x="502920" y="1188720"/>
+            <a:ext cx="11183112" cy="320040"/>
+          </a:xfrm>
+          <a:prstGeom prst="rect">
+            <a:avLst/>
+          </a:prstGeom>
+          <a:noFill/>
+        </p:spPr>
+        <p:txBody>
+          <a:bodyPr wrap="square">
+            <a:spAutoFit/>
+          </a:bodyPr>
+          <a:lstStyle/>
+          <a:p>
+            <a:pPr algn="l"/>
+            <a:r>
+              <a:rPr sz="1200" b="0" i="1">
+                <a:solidFill>
+                  <a:srgbClr val="555555"/>
+                </a:solidFill>
+              </a:rPr>
+              <a:t>Always link the GRN to the correct Reference PR — this is how the system connects deliveries to the original purchase request.</a:t>
+            </a:r>
+          </a:p>
+        </p:txBody>
+      </p:sp>
+      <p:sp>
+        <p:nvSpPr>
+          <p:cNvPr id="5" name="Oval 4"/>
           <p:cNvSpPr/>
           <p:nvPr/>
         </p:nvSpPr>
         <p:spPr>
           <a:xfrm>
-            <a:off x="502920" y="1243584"/>
+            <a:off x="502920" y="1591056"/>
             <a:ext cx="411480" cy="411480"/>
           </a:xfrm>
           <a:prstGeom prst="ellipse">
@@ -5129,13 +4858,13 @@
       </p:sp>
       <p:sp>
         <p:nvSpPr>
-          <p:cNvPr id="5" name="TextBox 4"/>
+          <p:cNvPr id="6" name="TextBox 5"/>
           <p:cNvSpPr txBox="1"/>
           <p:nvPr/>
         </p:nvSpPr>
         <p:spPr>
           <a:xfrm>
-            <a:off x="1033272" y="1188720"/>
+            <a:off x="1033272" y="1536192"/>
             <a:ext cx="10634472" cy="566928"/>
           </a:xfrm>
           <a:prstGeom prst="rect">
@@ -5156,20 +4885,20 @@
                   <a:srgbClr val="111111"/>
                 </a:solidFill>
               </a:rPr>
-              <a:t>Confirm the GRN is approved (check Stock Register or GRN list).</a:t>
-            </a:r>
-          </a:p>
-        </p:txBody>
-      </p:sp>
-      <p:sp>
-        <p:nvSpPr>
-          <p:cNvPr id="6" name="Oval 5"/>
+              <a:t>Sidebar → Stores → Create GRN.</a:t>
+            </a:r>
+          </a:p>
+        </p:txBody>
+      </p:sp>
+      <p:sp>
+        <p:nvSpPr>
+          <p:cNvPr id="7" name="Oval 6"/>
           <p:cNvSpPr/>
           <p:nvPr/>
         </p:nvSpPr>
         <p:spPr>
           <a:xfrm>
-            <a:off x="502920" y="1810512"/>
+            <a:off x="502920" y="2157984"/>
             <a:ext cx="411480" cy="411480"/>
           </a:xfrm>
           <a:prstGeom prst="ellipse">
@@ -5214,13 +4943,13 @@
       </p:sp>
       <p:sp>
         <p:nvSpPr>
-          <p:cNvPr id="7" name="TextBox 6"/>
+          <p:cNvPr id="8" name="TextBox 7"/>
           <p:cNvSpPr txBox="1"/>
           <p:nvPr/>
         </p:nvSpPr>
         <p:spPr>
           <a:xfrm>
-            <a:off x="1033272" y="1755648"/>
+            <a:off x="1033272" y="2103120"/>
             <a:ext cx="10634472" cy="566928"/>
           </a:xfrm>
           <a:prstGeom prst="rect">
@@ -5241,20 +4970,20 @@
                   <a:srgbClr val="111111"/>
                 </a:solidFill>
               </a:rPr>
-              <a:t>Sidebar → Stores → Create Issue Slip.</a:t>
-            </a:r>
-          </a:p>
-        </p:txBody>
-      </p:sp>
-      <p:sp>
-        <p:nvSpPr>
-          <p:cNvPr id="8" name="Oval 7"/>
+              <a:t>Fill the header: GRN Date, Supplier/Vendor, Reference PR (the approved PR this delivery fulfils).</a:t>
+            </a:r>
+          </a:p>
+        </p:txBody>
+      </p:sp>
+      <p:sp>
+        <p:nvSpPr>
+          <p:cNvPr id="9" name="Oval 8"/>
           <p:cNvSpPr/>
           <p:nvPr/>
         </p:nvSpPr>
         <p:spPr>
           <a:xfrm>
-            <a:off x="502920" y="2377440"/>
+            <a:off x="502920" y="2724912"/>
             <a:ext cx="411480" cy="411480"/>
           </a:xfrm>
           <a:prstGeom prst="ellipse">
@@ -5299,13 +5028,13 @@
       </p:sp>
       <p:sp>
         <p:nvSpPr>
-          <p:cNvPr id="9" name="TextBox 8"/>
+          <p:cNvPr id="10" name="TextBox 9"/>
           <p:cNvSpPr txBox="1"/>
           <p:nvPr/>
         </p:nvSpPr>
         <p:spPr>
           <a:xfrm>
-            <a:off x="1033272" y="2322576"/>
+            <a:off x="1033272" y="2670048"/>
             <a:ext cx="10634472" cy="566928"/>
           </a:xfrm>
           <a:prstGeom prst="rect">
@@ -5326,20 +5055,20 @@
                   <a:srgbClr val="111111"/>
                 </a:solidFill>
               </a:rPr>
-              <a:t>Fill: Issued To (person / department), Delivery Location, Reference GRN number.</a:t>
-            </a:r>
-          </a:p>
-        </p:txBody>
-      </p:sp>
-      <p:sp>
-        <p:nvSpPr>
-          <p:cNvPr id="10" name="Oval 9"/>
+              <a:t>Add each item received: select stock item, enter quantity received, unit, and condition.</a:t>
+            </a:r>
+          </a:p>
+        </p:txBody>
+      </p:sp>
+      <p:sp>
+        <p:nvSpPr>
+          <p:cNvPr id="11" name="Oval 10"/>
           <p:cNvSpPr/>
           <p:nvPr/>
         </p:nvSpPr>
         <p:spPr>
           <a:xfrm>
-            <a:off x="502920" y="2944368"/>
+            <a:off x="502920" y="3291840"/>
             <a:ext cx="411480" cy="411480"/>
           </a:xfrm>
           <a:prstGeom prst="ellipse">
@@ -5384,13 +5113,13 @@
       </p:sp>
       <p:sp>
         <p:nvSpPr>
-          <p:cNvPr id="11" name="TextBox 10"/>
+          <p:cNvPr id="12" name="TextBox 11"/>
           <p:cNvSpPr txBox="1"/>
           <p:nvPr/>
         </p:nvSpPr>
         <p:spPr>
           <a:xfrm>
-            <a:off x="1033272" y="2889504"/>
+            <a:off x="1033272" y="3236976"/>
             <a:ext cx="10634472" cy="566928"/>
           </a:xfrm>
           <a:prstGeom prst="rect">
@@ -5411,20 +5140,20 @@
                   <a:srgbClr val="111111"/>
                 </a:solidFill>
               </a:rPr>
-              <a:t>If GRN is customer-reserved, the Customer field must match the GRN.</a:t>
-            </a:r>
-          </a:p>
-        </p:txBody>
-      </p:sp>
-      <p:sp>
-        <p:nvSpPr>
-          <p:cNvPr id="12" name="Oval 11"/>
+              <a:t>If the GRN is for a specific customer, set the Customer field.</a:t>
+            </a:r>
+          </a:p>
+        </p:txBody>
+      </p:sp>
+      <p:sp>
+        <p:nvSpPr>
+          <p:cNvPr id="13" name="Oval 12"/>
           <p:cNvSpPr/>
           <p:nvPr/>
         </p:nvSpPr>
         <p:spPr>
           <a:xfrm>
-            <a:off x="502920" y="3511296"/>
+            <a:off x="502920" y="3858768"/>
             <a:ext cx="411480" cy="411480"/>
           </a:xfrm>
           <a:prstGeom prst="ellipse">
@@ -5469,13 +5198,13 @@
       </p:sp>
       <p:sp>
         <p:nvSpPr>
-          <p:cNvPr id="13" name="TextBox 12"/>
+          <p:cNvPr id="14" name="TextBox 13"/>
           <p:cNvSpPr txBox="1"/>
           <p:nvPr/>
         </p:nvSpPr>
         <p:spPr>
           <a:xfrm>
-            <a:off x="1033272" y="3456432"/>
+            <a:off x="1033272" y="3803904"/>
             <a:ext cx="10634472" cy="566928"/>
           </a:xfrm>
           <a:prstGeom prst="rect">
@@ -5496,20 +5225,20 @@
                   <a:srgbClr val="111111"/>
                 </a:solidFill>
               </a:rPr>
-              <a:t>Add each item: select stock item, enter quantity to issue. The system blocks over-issue automatically.</a:t>
-            </a:r>
-          </a:p>
-        </p:txBody>
-      </p:sp>
-      <p:sp>
-        <p:nvSpPr>
-          <p:cNvPr id="14" name="Oval 13"/>
+              <a:t>Attach the supplier delivery note or invoice.</a:t>
+            </a:r>
+          </a:p>
+        </p:txBody>
+      </p:sp>
+      <p:sp>
+        <p:nvSpPr>
+          <p:cNvPr id="15" name="Oval 14"/>
           <p:cNvSpPr/>
           <p:nvPr/>
         </p:nvSpPr>
         <p:spPr>
           <a:xfrm>
-            <a:off x="502920" y="4078224"/>
+            <a:off x="502920" y="4425696"/>
             <a:ext cx="411480" cy="411480"/>
           </a:xfrm>
           <a:prstGeom prst="ellipse">
@@ -5554,13 +5283,13 @@
       </p:sp>
       <p:sp>
         <p:nvSpPr>
-          <p:cNvPr id="15" name="TextBox 14"/>
+          <p:cNvPr id="16" name="TextBox 15"/>
           <p:cNvSpPr txBox="1"/>
           <p:nvPr/>
         </p:nvSpPr>
         <p:spPr>
           <a:xfrm>
-            <a:off x="1033272" y="4023360"/>
+            <a:off x="1033272" y="4370832"/>
             <a:ext cx="10634472" cy="566928"/>
           </a:xfrm>
           <a:prstGeom prst="rect">
@@ -5581,20 +5310,20 @@
                   <a:srgbClr val="111111"/>
                 </a:solidFill>
               </a:rPr>
-              <a:t>Click Submit. Goes to pending_hod → pending_finance for approval.</a:t>
-            </a:r>
-          </a:p>
-        </p:txBody>
-      </p:sp>
-      <p:sp>
-        <p:nvSpPr>
-          <p:cNvPr id="16" name="Oval 15"/>
+              <a:t>Click Submit. Status becomes pending_approval. Finance will review and approve.</a:t>
+            </a:r>
+          </a:p>
+        </p:txBody>
+      </p:sp>
+      <p:sp>
+        <p:nvSpPr>
+          <p:cNvPr id="17" name="Oval 16"/>
           <p:cNvSpPr/>
           <p:nvPr/>
         </p:nvSpPr>
         <p:spPr>
           <a:xfrm>
-            <a:off x="502920" y="4645152"/>
+            <a:off x="502920" y="4992624"/>
             <a:ext cx="411480" cy="411480"/>
           </a:xfrm>
           <a:prstGeom prst="ellipse">
@@ -5639,13 +5368,13 @@
       </p:sp>
       <p:sp>
         <p:nvSpPr>
-          <p:cNvPr id="17" name="TextBox 16"/>
+          <p:cNvPr id="18" name="TextBox 17"/>
           <p:cNvSpPr txBox="1"/>
           <p:nvPr/>
         </p:nvSpPr>
         <p:spPr>
           <a:xfrm>
-            <a:off x="1033272" y="4590288"/>
+            <a:off x="1033272" y="4937760"/>
             <a:ext cx="10634472" cy="566928"/>
           </a:xfrm>
           <a:prstGeom prst="rect">
@@ -5666,7 +5395,7 @@
                   <a:srgbClr val="111111"/>
                 </a:solidFill>
               </a:rPr>
-              <a:t>After Finance approval, stock is officially deducted from the register. Hand over the goods.</a:t>
+              <a:t>Only after Finance approval can stock be drawn via Issue Slips.</a:t>
             </a:r>
           </a:p>
         </p:txBody>
@@ -5761,174 +5490,27 @@
                   <a:srgbClr val="FFFFFF"/>
                 </a:solidFill>
               </a:rPr>
-              <a:t>Picking Slips &amp; Stock Register</a:t>
-            </a:r>
-          </a:p>
-        </p:txBody>
-      </p:sp>
-      <p:sp>
-        <p:nvSpPr>
-          <p:cNvPr id="4" name="TextBox 3"/>
-          <p:cNvSpPr txBox="1"/>
-          <p:nvPr/>
-        </p:nvSpPr>
-        <p:spPr>
-          <a:xfrm>
-            <a:off x="502920" y="1188720"/>
-            <a:ext cx="5454396" cy="347472"/>
-          </a:xfrm>
-          <a:prstGeom prst="rect">
-            <a:avLst/>
-          </a:prstGeom>
-          <a:noFill/>
-        </p:spPr>
-        <p:txBody>
-          <a:bodyPr wrap="square">
-            <a:spAutoFit/>
-          </a:bodyPr>
-          <a:lstStyle/>
-          <a:p>
-            <a:pPr algn="l"/>
-            <a:r>
-              <a:rPr sz="1300" b="1" i="0">
-                <a:solidFill>
-                  <a:srgbClr val="0B4A8A"/>
-                </a:solidFill>
-              </a:rPr>
-              <a:t>Picking Slip (stock movement)</a:t>
-            </a:r>
-          </a:p>
-        </p:txBody>
-      </p:sp>
-      <p:sp>
-        <p:nvSpPr>
-          <p:cNvPr id="5" name="TextBox 4"/>
-          <p:cNvSpPr txBox="1"/>
-          <p:nvPr/>
-        </p:nvSpPr>
-        <p:spPr>
-          <a:xfrm>
-            <a:off x="502920" y="1554480"/>
-            <a:ext cx="5454396" cy="5074920"/>
-          </a:xfrm>
-          <a:prstGeom prst="rect">
-            <a:avLst/>
-          </a:prstGeom>
-          <a:noFill/>
-        </p:spPr>
-        <p:txBody>
-          <a:bodyPr wrap="square">
-            <a:spAutoFit/>
-          </a:bodyPr>
-          <a:lstStyle/>
-          <a:p>
-            <a:pPr>
-              <a:spcBef>
-                <a:spcPts val="300"/>
-              </a:spcBef>
-            </a:pPr>
-            <a:r>
-              <a:rPr sz="1300">
-                <a:solidFill>
-                  <a:srgbClr val="111111"/>
-                </a:solidFill>
-              </a:rPr>
-              <a:t>No approval — completed immediately</a:t>
-            </a:r>
-          </a:p>
-          <a:p>
-            <a:pPr>
-              <a:spcBef>
-                <a:spcPts val="300"/>
-              </a:spcBef>
-            </a:pPr>
-            <a:r>
-              <a:rPr sz="1300">
-                <a:solidFill>
-                  <a:srgbClr val="111111"/>
-                </a:solidFill>
-              </a:rPr>
-              <a:t>Use when physically moving stock between storage areas (e.g. Bay 1 → Bay 3)</a:t>
-            </a:r>
-          </a:p>
-          <a:p>
-            <a:pPr>
-              <a:spcBef>
-                <a:spcPts val="300"/>
-              </a:spcBef>
-            </a:pPr>
-            <a:r>
-              <a:rPr sz="1300">
-                <a:solidFill>
-                  <a:srgbClr val="111111"/>
-                </a:solidFill>
-              </a:rPr>
-              <a:t>Sidebar → Stores → Create Picking Slip</a:t>
-            </a:r>
-          </a:p>
-          <a:p>
-            <a:pPr>
-              <a:spcBef>
-                <a:spcPts val="300"/>
-              </a:spcBef>
-            </a:pPr>
-            <a:r>
-              <a:rPr sz="1300">
-                <a:solidFill>
-                  <a:srgbClr val="111111"/>
-                </a:solidFill>
-              </a:rPr>
-              <a:t>Fill: from location, to location, items and quantities</a:t>
-            </a:r>
-          </a:p>
-          <a:p>
-            <a:pPr>
-              <a:spcBef>
-                <a:spcPts val="300"/>
-              </a:spcBef>
-            </a:pPr>
-            <a:r>
-              <a:rPr sz="1300">
-                <a:solidFill>
-                  <a:srgbClr val="111111"/>
-                </a:solidFill>
-              </a:rPr>
-              <a:t>Submit → status = completed instantly</a:t>
-            </a:r>
-          </a:p>
-          <a:p>
-            <a:pPr>
-              <a:spcBef>
-                <a:spcPts val="300"/>
-              </a:spcBef>
-            </a:pPr>
-            <a:r>
-              <a:rPr sz="1300">
-                <a:solidFill>
-                  <a:srgbClr val="111111"/>
-                </a:solidFill>
-              </a:rPr>
-              <a:t>The register reflects the movement immediately</a:t>
-            </a:r>
-          </a:p>
-        </p:txBody>
-      </p:sp>
-      <p:sp>
-        <p:nvSpPr>
-          <p:cNvPr id="6" name="Rectangle 5"/>
+              <a:t>Task: Create an Issue Slip</a:t>
+            </a:r>
+          </a:p>
+        </p:txBody>
+      </p:sp>
+      <p:sp>
+        <p:nvSpPr>
+          <p:cNvPr id="4" name="Oval 3"/>
           <p:cNvSpPr/>
           <p:nvPr/>
         </p:nvSpPr>
         <p:spPr>
           <a:xfrm>
-            <a:off x="6067044" y="1188720"/>
-            <a:ext cx="27432" cy="5349240"/>
-          </a:xfrm>
-          <a:prstGeom prst="rect">
+            <a:off x="502920" y="1243584"/>
+            <a:ext cx="411480" cy="411480"/>
+          </a:xfrm>
+          <a:prstGeom prst="ellipse">
             <a:avLst/>
           </a:prstGeom>
           <a:solidFill>
-            <a:srgbClr val="CCDDEE"/>
+            <a:srgbClr val="0B4A8A"/>
           </a:solidFill>
           <a:ln>
             <a:noFill/>
@@ -5953,6 +5535,99 @@
           <a:lstStyle/>
           <a:p>
             <a:pPr algn="ctr"/>
+            <a:r>
+              <a:rPr sz="1200" b="1">
+                <a:solidFill>
+                  <a:srgbClr val="FFFFFF"/>
+                </a:solidFill>
+              </a:rPr>
+              <a:t>1</a:t>
+            </a:r>
+          </a:p>
+        </p:txBody>
+      </p:sp>
+      <p:sp>
+        <p:nvSpPr>
+          <p:cNvPr id="5" name="TextBox 4"/>
+          <p:cNvSpPr txBox="1"/>
+          <p:nvPr/>
+        </p:nvSpPr>
+        <p:spPr>
+          <a:xfrm>
+            <a:off x="1033272" y="1188720"/>
+            <a:ext cx="10634472" cy="566928"/>
+          </a:xfrm>
+          <a:prstGeom prst="rect">
+            <a:avLst/>
+          </a:prstGeom>
+          <a:noFill/>
+        </p:spPr>
+        <p:txBody>
+          <a:bodyPr wrap="square">
+            <a:spAutoFit/>
+          </a:bodyPr>
+          <a:lstStyle/>
+          <a:p>
+            <a:pPr algn="l"/>
+            <a:r>
+              <a:rPr sz="1300" b="0" i="0">
+                <a:solidFill>
+                  <a:srgbClr val="111111"/>
+                </a:solidFill>
+              </a:rPr>
+              <a:t>Confirm the GRN is approved (check Stock Register or GRN list).</a:t>
+            </a:r>
+          </a:p>
+        </p:txBody>
+      </p:sp>
+      <p:sp>
+        <p:nvSpPr>
+          <p:cNvPr id="6" name="Oval 5"/>
+          <p:cNvSpPr/>
+          <p:nvPr/>
+        </p:nvSpPr>
+        <p:spPr>
+          <a:xfrm>
+            <a:off x="502920" y="1810512"/>
+            <a:ext cx="411480" cy="411480"/>
+          </a:xfrm>
+          <a:prstGeom prst="ellipse">
+            <a:avLst/>
+          </a:prstGeom>
+          <a:solidFill>
+            <a:srgbClr val="0B4A8A"/>
+          </a:solidFill>
+          <a:ln>
+            <a:noFill/>
+          </a:ln>
+        </p:spPr>
+        <p:style>
+          <a:lnRef idx="1">
+            <a:schemeClr val="accent1"/>
+          </a:lnRef>
+          <a:fillRef idx="3">
+            <a:schemeClr val="accent1"/>
+          </a:fillRef>
+          <a:effectRef idx="2">
+            <a:schemeClr val="accent1"/>
+          </a:effectRef>
+          <a:fontRef idx="minor">
+            <a:schemeClr val="lt1"/>
+          </a:fontRef>
+        </p:style>
+        <p:txBody>
+          <a:bodyPr rtlCol="0" anchor="ctr"/>
+          <a:lstStyle/>
+          <a:p>
+            <a:pPr algn="ctr"/>
+            <a:r>
+              <a:rPr sz="1200" b="1">
+                <a:solidFill>
+                  <a:srgbClr val="FFFFFF"/>
+                </a:solidFill>
+              </a:rPr>
+              <a:t>2</a:t>
+            </a:r>
           </a:p>
         </p:txBody>
       </p:sp>
@@ -5964,8 +5639,8 @@
         </p:nvSpPr>
         <p:spPr>
           <a:xfrm>
-            <a:off x="6231636" y="1188720"/>
-            <a:ext cx="5454396" cy="347472"/>
+            <a:off x="1033272" y="1755648"/>
+            <a:ext cx="10634472" cy="566928"/>
           </a:xfrm>
           <a:prstGeom prst="rect">
             <a:avLst/>
@@ -5980,26 +5655,77 @@
           <a:p>
             <a:pPr algn="l"/>
             <a:r>
-              <a:rPr sz="1300" b="1" i="0">
-                <a:solidFill>
-                  <a:srgbClr val="0B4A8A"/>
-                </a:solidFill>
-              </a:rPr>
-              <a:t>Real-Time Stock Register</a:t>
-            </a:r>
-          </a:p>
-        </p:txBody>
-      </p:sp>
-      <p:sp>
-        <p:nvSpPr>
-          <p:cNvPr id="8" name="TextBox 7"/>
+              <a:rPr sz="1300" b="0" i="0">
+                <a:solidFill>
+                  <a:srgbClr val="111111"/>
+                </a:solidFill>
+              </a:rPr>
+              <a:t>Sidebar → Stores → Create Issue Slip.</a:t>
+            </a:r>
+          </a:p>
+        </p:txBody>
+      </p:sp>
+      <p:sp>
+        <p:nvSpPr>
+          <p:cNvPr id="8" name="Oval 7"/>
+          <p:cNvSpPr/>
+          <p:nvPr/>
+        </p:nvSpPr>
+        <p:spPr>
+          <a:xfrm>
+            <a:off x="502920" y="2377440"/>
+            <a:ext cx="411480" cy="411480"/>
+          </a:xfrm>
+          <a:prstGeom prst="ellipse">
+            <a:avLst/>
+          </a:prstGeom>
+          <a:solidFill>
+            <a:srgbClr val="0B4A8A"/>
+          </a:solidFill>
+          <a:ln>
+            <a:noFill/>
+          </a:ln>
+        </p:spPr>
+        <p:style>
+          <a:lnRef idx="1">
+            <a:schemeClr val="accent1"/>
+          </a:lnRef>
+          <a:fillRef idx="3">
+            <a:schemeClr val="accent1"/>
+          </a:fillRef>
+          <a:effectRef idx="2">
+            <a:schemeClr val="accent1"/>
+          </a:effectRef>
+          <a:fontRef idx="minor">
+            <a:schemeClr val="lt1"/>
+          </a:fontRef>
+        </p:style>
+        <p:txBody>
+          <a:bodyPr rtlCol="0" anchor="ctr"/>
+          <a:lstStyle/>
+          <a:p>
+            <a:pPr algn="ctr"/>
+            <a:r>
+              <a:rPr sz="1200" b="1">
+                <a:solidFill>
+                  <a:srgbClr val="FFFFFF"/>
+                </a:solidFill>
+              </a:rPr>
+              <a:t>3</a:t>
+            </a:r>
+          </a:p>
+        </p:txBody>
+      </p:sp>
+      <p:sp>
+        <p:nvSpPr>
+          <p:cNvPr id="9" name="TextBox 8"/>
           <p:cNvSpPr txBox="1"/>
           <p:nvPr/>
         </p:nvSpPr>
         <p:spPr>
           <a:xfrm>
-            <a:off x="6231636" y="1554480"/>
-            <a:ext cx="5454396" cy="5074920"/>
+            <a:off x="1033272" y="2322576"/>
+            <a:ext cx="10634472" cy="566928"/>
           </a:xfrm>
           <a:prstGeom prst="rect">
             <a:avLst/>
@@ -6012,123 +5738,354 @@
           </a:bodyPr>
           <a:lstStyle/>
           <a:p>
-            <a:pPr>
-              <a:spcBef>
-                <a:spcPts val="300"/>
-              </a:spcBef>
-            </a:pPr>
-            <a:r>
-              <a:rPr sz="1300">
-                <a:solidFill>
-                  <a:srgbClr val="111111"/>
-                </a:solidFill>
-              </a:rPr>
-              <a:t>Sidebar → Stores → Real-Time Stock Register</a:t>
-            </a:r>
-          </a:p>
-          <a:p>
-            <a:pPr>
-              <a:spcBef>
-                <a:spcPts val="300"/>
-              </a:spcBef>
-            </a:pPr>
-            <a:r>
-              <a:rPr sz="1300">
-                <a:solidFill>
-                  <a:srgbClr val="111111"/>
-                </a:solidFill>
-              </a:rPr>
-              <a:t>Shows: Stock In (all approved GRNs) minus Stock Out (approved Issue Slips) minus Reserved</a:t>
-            </a:r>
-          </a:p>
-          <a:p>
-            <a:pPr>
-              <a:spcBef>
-                <a:spcPts val="300"/>
-              </a:spcBef>
-            </a:pPr>
-            <a:r>
-              <a:rPr sz="1300">
-                <a:solidFill>
-                  <a:srgbClr val="111111"/>
-                </a:solidFill>
-              </a:rPr>
-              <a:t>Available = what can currently be issued</a:t>
-            </a:r>
-          </a:p>
-          <a:p>
-            <a:pPr>
-              <a:spcBef>
-                <a:spcPts val="300"/>
-              </a:spcBef>
-            </a:pPr>
-            <a:r>
-              <a:rPr sz="1300">
-                <a:solidFill>
-                  <a:srgbClr val="111111"/>
-                </a:solidFill>
-              </a:rPr>
-              <a:t>Use this before creating an Issue Slip to confirm enough stock exists</a:t>
-            </a:r>
-          </a:p>
-          <a:p>
-            <a:pPr>
-              <a:spcBef>
-                <a:spcPts val="600"/>
-              </a:spcBef>
-            </a:pPr>
-            <a:r>
-              <a:rPr sz="1400" b="1">
-                <a:solidFill>
-                  <a:srgbClr val="0B4A8A"/>
-                </a:solidFill>
-              </a:rPr>
-              <a:t>Stock Items</a:t>
-            </a:r>
-          </a:p>
-          <a:p>
-            <a:pPr>
-              <a:spcBef>
-                <a:spcPts val="300"/>
-              </a:spcBef>
-            </a:pPr>
-            <a:r>
-              <a:rPr sz="1300">
-                <a:solidFill>
-                  <a:srgbClr val="111111"/>
-                </a:solidFill>
-              </a:rPr>
-              <a:t>Sidebar → Stores → Stock Items</a:t>
-            </a:r>
-          </a:p>
-          <a:p>
-            <a:pPr>
-              <a:spcBef>
-                <a:spcPts val="300"/>
-              </a:spcBef>
-            </a:pPr>
-            <a:r>
-              <a:rPr sz="1300">
-                <a:solidFill>
-                  <a:srgbClr val="111111"/>
-                </a:solidFill>
-              </a:rPr>
-              <a:t>Add or edit catalogue entries (name, unit, description, category)</a:t>
-            </a:r>
-          </a:p>
-          <a:p>
-            <a:pPr>
-              <a:spcBef>
-                <a:spcPts val="300"/>
-              </a:spcBef>
-            </a:pPr>
-            <a:r>
-              <a:rPr sz="1300">
-                <a:solidFill>
-                  <a:srgbClr val="111111"/>
-                </a:solidFill>
-              </a:rPr>
-              <a:t>Avoid duplicate descriptions — one record per item type</a:t>
+            <a:pPr algn="l"/>
+            <a:r>
+              <a:rPr sz="1300" b="0" i="0">
+                <a:solidFill>
+                  <a:srgbClr val="111111"/>
+                </a:solidFill>
+              </a:rPr>
+              <a:t>Fill: Issued To (person / department), Delivery Location, Reference GRN number.</a:t>
+            </a:r>
+          </a:p>
+        </p:txBody>
+      </p:sp>
+      <p:sp>
+        <p:nvSpPr>
+          <p:cNvPr id="10" name="Oval 9"/>
+          <p:cNvSpPr/>
+          <p:nvPr/>
+        </p:nvSpPr>
+        <p:spPr>
+          <a:xfrm>
+            <a:off x="502920" y="2944368"/>
+            <a:ext cx="411480" cy="411480"/>
+          </a:xfrm>
+          <a:prstGeom prst="ellipse">
+            <a:avLst/>
+          </a:prstGeom>
+          <a:solidFill>
+            <a:srgbClr val="0B4A8A"/>
+          </a:solidFill>
+          <a:ln>
+            <a:noFill/>
+          </a:ln>
+        </p:spPr>
+        <p:style>
+          <a:lnRef idx="1">
+            <a:schemeClr val="accent1"/>
+          </a:lnRef>
+          <a:fillRef idx="3">
+            <a:schemeClr val="accent1"/>
+          </a:fillRef>
+          <a:effectRef idx="2">
+            <a:schemeClr val="accent1"/>
+          </a:effectRef>
+          <a:fontRef idx="minor">
+            <a:schemeClr val="lt1"/>
+          </a:fontRef>
+        </p:style>
+        <p:txBody>
+          <a:bodyPr rtlCol="0" anchor="ctr"/>
+          <a:lstStyle/>
+          <a:p>
+            <a:pPr algn="ctr"/>
+            <a:r>
+              <a:rPr sz="1200" b="1">
+                <a:solidFill>
+                  <a:srgbClr val="FFFFFF"/>
+                </a:solidFill>
+              </a:rPr>
+              <a:t>4</a:t>
+            </a:r>
+          </a:p>
+        </p:txBody>
+      </p:sp>
+      <p:sp>
+        <p:nvSpPr>
+          <p:cNvPr id="11" name="TextBox 10"/>
+          <p:cNvSpPr txBox="1"/>
+          <p:nvPr/>
+        </p:nvSpPr>
+        <p:spPr>
+          <a:xfrm>
+            <a:off x="1033272" y="2889504"/>
+            <a:ext cx="10634472" cy="566928"/>
+          </a:xfrm>
+          <a:prstGeom prst="rect">
+            <a:avLst/>
+          </a:prstGeom>
+          <a:noFill/>
+        </p:spPr>
+        <p:txBody>
+          <a:bodyPr wrap="square">
+            <a:spAutoFit/>
+          </a:bodyPr>
+          <a:lstStyle/>
+          <a:p>
+            <a:pPr algn="l"/>
+            <a:r>
+              <a:rPr sz="1300" b="0" i="0">
+                <a:solidFill>
+                  <a:srgbClr val="111111"/>
+                </a:solidFill>
+              </a:rPr>
+              <a:t>If GRN is customer-reserved, the Customer field must match the GRN.</a:t>
+            </a:r>
+          </a:p>
+        </p:txBody>
+      </p:sp>
+      <p:sp>
+        <p:nvSpPr>
+          <p:cNvPr id="12" name="Oval 11"/>
+          <p:cNvSpPr/>
+          <p:nvPr/>
+        </p:nvSpPr>
+        <p:spPr>
+          <a:xfrm>
+            <a:off x="502920" y="3511296"/>
+            <a:ext cx="411480" cy="411480"/>
+          </a:xfrm>
+          <a:prstGeom prst="ellipse">
+            <a:avLst/>
+          </a:prstGeom>
+          <a:solidFill>
+            <a:srgbClr val="0B4A8A"/>
+          </a:solidFill>
+          <a:ln>
+            <a:noFill/>
+          </a:ln>
+        </p:spPr>
+        <p:style>
+          <a:lnRef idx="1">
+            <a:schemeClr val="accent1"/>
+          </a:lnRef>
+          <a:fillRef idx="3">
+            <a:schemeClr val="accent1"/>
+          </a:fillRef>
+          <a:effectRef idx="2">
+            <a:schemeClr val="accent1"/>
+          </a:effectRef>
+          <a:fontRef idx="minor">
+            <a:schemeClr val="lt1"/>
+          </a:fontRef>
+        </p:style>
+        <p:txBody>
+          <a:bodyPr rtlCol="0" anchor="ctr"/>
+          <a:lstStyle/>
+          <a:p>
+            <a:pPr algn="ctr"/>
+            <a:r>
+              <a:rPr sz="1200" b="1">
+                <a:solidFill>
+                  <a:srgbClr val="FFFFFF"/>
+                </a:solidFill>
+              </a:rPr>
+              <a:t>5</a:t>
+            </a:r>
+          </a:p>
+        </p:txBody>
+      </p:sp>
+      <p:sp>
+        <p:nvSpPr>
+          <p:cNvPr id="13" name="TextBox 12"/>
+          <p:cNvSpPr txBox="1"/>
+          <p:nvPr/>
+        </p:nvSpPr>
+        <p:spPr>
+          <a:xfrm>
+            <a:off x="1033272" y="3456432"/>
+            <a:ext cx="10634472" cy="566928"/>
+          </a:xfrm>
+          <a:prstGeom prst="rect">
+            <a:avLst/>
+          </a:prstGeom>
+          <a:noFill/>
+        </p:spPr>
+        <p:txBody>
+          <a:bodyPr wrap="square">
+            <a:spAutoFit/>
+          </a:bodyPr>
+          <a:lstStyle/>
+          <a:p>
+            <a:pPr algn="l"/>
+            <a:r>
+              <a:rPr sz="1300" b="0" i="0">
+                <a:solidFill>
+                  <a:srgbClr val="111111"/>
+                </a:solidFill>
+              </a:rPr>
+              <a:t>Add each item: select stock item, enter quantity to issue. The system blocks over-issue automatically.</a:t>
+            </a:r>
+          </a:p>
+        </p:txBody>
+      </p:sp>
+      <p:sp>
+        <p:nvSpPr>
+          <p:cNvPr id="14" name="Oval 13"/>
+          <p:cNvSpPr/>
+          <p:nvPr/>
+        </p:nvSpPr>
+        <p:spPr>
+          <a:xfrm>
+            <a:off x="502920" y="4078224"/>
+            <a:ext cx="411480" cy="411480"/>
+          </a:xfrm>
+          <a:prstGeom prst="ellipse">
+            <a:avLst/>
+          </a:prstGeom>
+          <a:solidFill>
+            <a:srgbClr val="0B4A8A"/>
+          </a:solidFill>
+          <a:ln>
+            <a:noFill/>
+          </a:ln>
+        </p:spPr>
+        <p:style>
+          <a:lnRef idx="1">
+            <a:schemeClr val="accent1"/>
+          </a:lnRef>
+          <a:fillRef idx="3">
+            <a:schemeClr val="accent1"/>
+          </a:fillRef>
+          <a:effectRef idx="2">
+            <a:schemeClr val="accent1"/>
+          </a:effectRef>
+          <a:fontRef idx="minor">
+            <a:schemeClr val="lt1"/>
+          </a:fontRef>
+        </p:style>
+        <p:txBody>
+          <a:bodyPr rtlCol="0" anchor="ctr"/>
+          <a:lstStyle/>
+          <a:p>
+            <a:pPr algn="ctr"/>
+            <a:r>
+              <a:rPr sz="1200" b="1">
+                <a:solidFill>
+                  <a:srgbClr val="FFFFFF"/>
+                </a:solidFill>
+              </a:rPr>
+              <a:t>6</a:t>
+            </a:r>
+          </a:p>
+        </p:txBody>
+      </p:sp>
+      <p:sp>
+        <p:nvSpPr>
+          <p:cNvPr id="15" name="TextBox 14"/>
+          <p:cNvSpPr txBox="1"/>
+          <p:nvPr/>
+        </p:nvSpPr>
+        <p:spPr>
+          <a:xfrm>
+            <a:off x="1033272" y="4023360"/>
+            <a:ext cx="10634472" cy="566928"/>
+          </a:xfrm>
+          <a:prstGeom prst="rect">
+            <a:avLst/>
+          </a:prstGeom>
+          <a:noFill/>
+        </p:spPr>
+        <p:txBody>
+          <a:bodyPr wrap="square">
+            <a:spAutoFit/>
+          </a:bodyPr>
+          <a:lstStyle/>
+          <a:p>
+            <a:pPr algn="l"/>
+            <a:r>
+              <a:rPr sz="1300" b="0" i="0">
+                <a:solidFill>
+                  <a:srgbClr val="111111"/>
+                </a:solidFill>
+              </a:rPr>
+              <a:t>Click Submit. Goes to pending_hod → pending_finance for approval.</a:t>
+            </a:r>
+          </a:p>
+        </p:txBody>
+      </p:sp>
+      <p:sp>
+        <p:nvSpPr>
+          <p:cNvPr id="16" name="Oval 15"/>
+          <p:cNvSpPr/>
+          <p:nvPr/>
+        </p:nvSpPr>
+        <p:spPr>
+          <a:xfrm>
+            <a:off x="502920" y="4645152"/>
+            <a:ext cx="411480" cy="411480"/>
+          </a:xfrm>
+          <a:prstGeom prst="ellipse">
+            <a:avLst/>
+          </a:prstGeom>
+          <a:solidFill>
+            <a:srgbClr val="0B4A8A"/>
+          </a:solidFill>
+          <a:ln>
+            <a:noFill/>
+          </a:ln>
+        </p:spPr>
+        <p:style>
+          <a:lnRef idx="1">
+            <a:schemeClr val="accent1"/>
+          </a:lnRef>
+          <a:fillRef idx="3">
+            <a:schemeClr val="accent1"/>
+          </a:fillRef>
+          <a:effectRef idx="2">
+            <a:schemeClr val="accent1"/>
+          </a:effectRef>
+          <a:fontRef idx="minor">
+            <a:schemeClr val="lt1"/>
+          </a:fontRef>
+        </p:style>
+        <p:txBody>
+          <a:bodyPr rtlCol="0" anchor="ctr"/>
+          <a:lstStyle/>
+          <a:p>
+            <a:pPr algn="ctr"/>
+            <a:r>
+              <a:rPr sz="1200" b="1">
+                <a:solidFill>
+                  <a:srgbClr val="FFFFFF"/>
+                </a:solidFill>
+              </a:rPr>
+              <a:t>7</a:t>
+            </a:r>
+          </a:p>
+        </p:txBody>
+      </p:sp>
+      <p:sp>
+        <p:nvSpPr>
+          <p:cNvPr id="17" name="TextBox 16"/>
+          <p:cNvSpPr txBox="1"/>
+          <p:nvPr/>
+        </p:nvSpPr>
+        <p:spPr>
+          <a:xfrm>
+            <a:off x="1033272" y="4590288"/>
+            <a:ext cx="10634472" cy="566928"/>
+          </a:xfrm>
+          <a:prstGeom prst="rect">
+            <a:avLst/>
+          </a:prstGeom>
+          <a:noFill/>
+        </p:spPr>
+        <p:txBody>
+          <a:bodyPr wrap="square">
+            <a:spAutoFit/>
+          </a:bodyPr>
+          <a:lstStyle/>
+          <a:p>
+            <a:pPr algn="l"/>
+            <a:r>
+              <a:rPr sz="1300" b="0" i="0">
+                <a:solidFill>
+                  <a:srgbClr val="111111"/>
+                </a:solidFill>
+              </a:rPr>
+              <a:t>After Finance approval, stock is officially deducted from the register. Hand over the goods.</a:t>
             </a:r>
           </a:p>
         </p:txBody>
@@ -6142,6 +6099,781 @@
 </file>
 
 <file path=ppt/slides/slide7.xml><?xml version="1.0" encoding="utf-8"?>
+<p:sld xmlns:a="http://schemas.openxmlformats.org/drawingml/2006/main" xmlns:p="http://schemas.openxmlformats.org/presentationml/2006/main" xmlns:r="http://schemas.openxmlformats.org/officeDocument/2006/relationships">
+  <p:cSld>
+    <p:spTree>
+      <p:nvGrpSpPr>
+        <p:cNvPr id="1" name=""/>
+        <p:cNvGrpSpPr/>
+        <p:nvPr/>
+      </p:nvGrpSpPr>
+      <p:grpSpPr/>
+      <p:sp>
+        <p:nvSpPr>
+          <p:cNvPr id="2" name="Rectangle 1"/>
+          <p:cNvSpPr/>
+          <p:nvPr/>
+        </p:nvSpPr>
+        <p:spPr>
+          <a:xfrm>
+            <a:off x="0" y="0"/>
+            <a:ext cx="12188952" cy="1051560"/>
+          </a:xfrm>
+          <a:prstGeom prst="rect">
+            <a:avLst/>
+          </a:prstGeom>
+          <a:solidFill>
+            <a:srgbClr val="0B4A8A"/>
+          </a:solidFill>
+          <a:ln>
+            <a:noFill/>
+          </a:ln>
+        </p:spPr>
+        <p:style>
+          <a:lnRef idx="1">
+            <a:schemeClr val="accent1"/>
+          </a:lnRef>
+          <a:fillRef idx="3">
+            <a:schemeClr val="accent1"/>
+          </a:fillRef>
+          <a:effectRef idx="2">
+            <a:schemeClr val="accent1"/>
+          </a:effectRef>
+          <a:fontRef idx="minor">
+            <a:schemeClr val="lt1"/>
+          </a:fontRef>
+        </p:style>
+        <p:txBody>
+          <a:bodyPr rtlCol="0" anchor="ctr"/>
+          <a:lstStyle/>
+          <a:p>
+            <a:pPr algn="ctr"/>
+          </a:p>
+        </p:txBody>
+      </p:sp>
+      <p:sp>
+        <p:nvSpPr>
+          <p:cNvPr id="3" name="TextBox 2"/>
+          <p:cNvSpPr txBox="1"/>
+          <p:nvPr/>
+        </p:nvSpPr>
+        <p:spPr>
+          <a:xfrm>
+            <a:off x="502920" y="274320"/>
+            <a:ext cx="11183112" cy="685800"/>
+          </a:xfrm>
+          <a:prstGeom prst="rect">
+            <a:avLst/>
+          </a:prstGeom>
+          <a:noFill/>
+        </p:spPr>
+        <p:txBody>
+          <a:bodyPr wrap="square">
+            <a:spAutoFit/>
+          </a:bodyPr>
+          <a:lstStyle/>
+          <a:p>
+            <a:pPr algn="l"/>
+            <a:r>
+              <a:rPr sz="2200" b="1" i="0">
+                <a:solidFill>
+                  <a:srgbClr val="FFFFFF"/>
+                </a:solidFill>
+              </a:rPr>
+              <a:t>Picking Slips &amp; Stock Register</a:t>
+            </a:r>
+          </a:p>
+        </p:txBody>
+      </p:sp>
+      <p:sp>
+        <p:nvSpPr>
+          <p:cNvPr id="4" name="TextBox 3"/>
+          <p:cNvSpPr txBox="1"/>
+          <p:nvPr/>
+        </p:nvSpPr>
+        <p:spPr>
+          <a:xfrm>
+            <a:off x="502920" y="1188720"/>
+            <a:ext cx="5454396" cy="347472"/>
+          </a:xfrm>
+          <a:prstGeom prst="rect">
+            <a:avLst/>
+          </a:prstGeom>
+          <a:noFill/>
+        </p:spPr>
+        <p:txBody>
+          <a:bodyPr wrap="square">
+            <a:spAutoFit/>
+          </a:bodyPr>
+          <a:lstStyle/>
+          <a:p>
+            <a:pPr algn="l"/>
+            <a:r>
+              <a:rPr sz="1300" b="1" i="0">
+                <a:solidFill>
+                  <a:srgbClr val="0B4A8A"/>
+                </a:solidFill>
+              </a:rPr>
+              <a:t>Picking Slip (stock movement)</a:t>
+            </a:r>
+          </a:p>
+        </p:txBody>
+      </p:sp>
+      <p:sp>
+        <p:nvSpPr>
+          <p:cNvPr id="5" name="TextBox 4"/>
+          <p:cNvSpPr txBox="1"/>
+          <p:nvPr/>
+        </p:nvSpPr>
+        <p:spPr>
+          <a:xfrm>
+            <a:off x="502920" y="1554480"/>
+            <a:ext cx="5454396" cy="5074920"/>
+          </a:xfrm>
+          <a:prstGeom prst="rect">
+            <a:avLst/>
+          </a:prstGeom>
+          <a:noFill/>
+        </p:spPr>
+        <p:txBody>
+          <a:bodyPr wrap="square">
+            <a:spAutoFit/>
+          </a:bodyPr>
+          <a:lstStyle/>
+          <a:p>
+            <a:pPr>
+              <a:spcBef>
+                <a:spcPts val="300"/>
+              </a:spcBef>
+            </a:pPr>
+            <a:r>
+              <a:rPr sz="1300">
+                <a:solidFill>
+                  <a:srgbClr val="111111"/>
+                </a:solidFill>
+              </a:rPr>
+              <a:t>No approval — completed immediately</a:t>
+            </a:r>
+          </a:p>
+          <a:p>
+            <a:pPr>
+              <a:spcBef>
+                <a:spcPts val="300"/>
+              </a:spcBef>
+            </a:pPr>
+            <a:r>
+              <a:rPr sz="1300">
+                <a:solidFill>
+                  <a:srgbClr val="111111"/>
+                </a:solidFill>
+              </a:rPr>
+              <a:t>Use when physically moving stock between storage areas (e.g. Bay 1 → Bay 3)</a:t>
+            </a:r>
+          </a:p>
+          <a:p>
+            <a:pPr>
+              <a:spcBef>
+                <a:spcPts val="300"/>
+              </a:spcBef>
+            </a:pPr>
+            <a:r>
+              <a:rPr sz="1300">
+                <a:solidFill>
+                  <a:srgbClr val="111111"/>
+                </a:solidFill>
+              </a:rPr>
+              <a:t>Sidebar → Stores → Create Picking Slip</a:t>
+            </a:r>
+          </a:p>
+          <a:p>
+            <a:pPr>
+              <a:spcBef>
+                <a:spcPts val="300"/>
+              </a:spcBef>
+            </a:pPr>
+            <a:r>
+              <a:rPr sz="1300">
+                <a:solidFill>
+                  <a:srgbClr val="111111"/>
+                </a:solidFill>
+              </a:rPr>
+              <a:t>Fill: from location, to location, items and quantities</a:t>
+            </a:r>
+          </a:p>
+          <a:p>
+            <a:pPr>
+              <a:spcBef>
+                <a:spcPts val="300"/>
+              </a:spcBef>
+            </a:pPr>
+            <a:r>
+              <a:rPr sz="1300">
+                <a:solidFill>
+                  <a:srgbClr val="111111"/>
+                </a:solidFill>
+              </a:rPr>
+              <a:t>Submit → status = completed instantly</a:t>
+            </a:r>
+          </a:p>
+          <a:p>
+            <a:pPr>
+              <a:spcBef>
+                <a:spcPts val="300"/>
+              </a:spcBef>
+            </a:pPr>
+            <a:r>
+              <a:rPr sz="1300">
+                <a:solidFill>
+                  <a:srgbClr val="111111"/>
+                </a:solidFill>
+              </a:rPr>
+              <a:t>The register reflects the movement immediately</a:t>
+            </a:r>
+          </a:p>
+        </p:txBody>
+      </p:sp>
+      <p:sp>
+        <p:nvSpPr>
+          <p:cNvPr id="6" name="Rectangle 5"/>
+          <p:cNvSpPr/>
+          <p:nvPr/>
+        </p:nvSpPr>
+        <p:spPr>
+          <a:xfrm>
+            <a:off x="6067044" y="1188720"/>
+            <a:ext cx="27432" cy="5349240"/>
+          </a:xfrm>
+          <a:prstGeom prst="rect">
+            <a:avLst/>
+          </a:prstGeom>
+          <a:solidFill>
+            <a:srgbClr val="CCDDEE"/>
+          </a:solidFill>
+          <a:ln>
+            <a:noFill/>
+          </a:ln>
+        </p:spPr>
+        <p:style>
+          <a:lnRef idx="1">
+            <a:schemeClr val="accent1"/>
+          </a:lnRef>
+          <a:fillRef idx="3">
+            <a:schemeClr val="accent1"/>
+          </a:fillRef>
+          <a:effectRef idx="2">
+            <a:schemeClr val="accent1"/>
+          </a:effectRef>
+          <a:fontRef idx="minor">
+            <a:schemeClr val="lt1"/>
+          </a:fontRef>
+        </p:style>
+        <p:txBody>
+          <a:bodyPr rtlCol="0" anchor="ctr"/>
+          <a:lstStyle/>
+          <a:p>
+            <a:pPr algn="ctr"/>
+          </a:p>
+        </p:txBody>
+      </p:sp>
+      <p:sp>
+        <p:nvSpPr>
+          <p:cNvPr id="7" name="TextBox 6"/>
+          <p:cNvSpPr txBox="1"/>
+          <p:nvPr/>
+        </p:nvSpPr>
+        <p:spPr>
+          <a:xfrm>
+            <a:off x="6231636" y="1188720"/>
+            <a:ext cx="5454396" cy="347472"/>
+          </a:xfrm>
+          <a:prstGeom prst="rect">
+            <a:avLst/>
+          </a:prstGeom>
+          <a:noFill/>
+        </p:spPr>
+        <p:txBody>
+          <a:bodyPr wrap="square">
+            <a:spAutoFit/>
+          </a:bodyPr>
+          <a:lstStyle/>
+          <a:p>
+            <a:pPr algn="l"/>
+            <a:r>
+              <a:rPr sz="1300" b="1" i="0">
+                <a:solidFill>
+                  <a:srgbClr val="0B4A8A"/>
+                </a:solidFill>
+              </a:rPr>
+              <a:t>Real-Time Stock Register</a:t>
+            </a:r>
+          </a:p>
+        </p:txBody>
+      </p:sp>
+      <p:sp>
+        <p:nvSpPr>
+          <p:cNvPr id="8" name="TextBox 7"/>
+          <p:cNvSpPr txBox="1"/>
+          <p:nvPr/>
+        </p:nvSpPr>
+        <p:spPr>
+          <a:xfrm>
+            <a:off x="6231636" y="1554480"/>
+            <a:ext cx="5454396" cy="5074920"/>
+          </a:xfrm>
+          <a:prstGeom prst="rect">
+            <a:avLst/>
+          </a:prstGeom>
+          <a:noFill/>
+        </p:spPr>
+        <p:txBody>
+          <a:bodyPr wrap="square">
+            <a:spAutoFit/>
+          </a:bodyPr>
+          <a:lstStyle/>
+          <a:p>
+            <a:pPr>
+              <a:spcBef>
+                <a:spcPts val="300"/>
+              </a:spcBef>
+            </a:pPr>
+            <a:r>
+              <a:rPr sz="1300">
+                <a:solidFill>
+                  <a:srgbClr val="111111"/>
+                </a:solidFill>
+              </a:rPr>
+              <a:t>Sidebar → Stores → Real-Time Stock Register</a:t>
+            </a:r>
+          </a:p>
+          <a:p>
+            <a:pPr>
+              <a:spcBef>
+                <a:spcPts val="300"/>
+              </a:spcBef>
+            </a:pPr>
+            <a:r>
+              <a:rPr sz="1300">
+                <a:solidFill>
+                  <a:srgbClr val="111111"/>
+                </a:solidFill>
+              </a:rPr>
+              <a:t>Shows: Stock In (approved GRNs) minus Stock Out (approved Issue Slips) minus Reserved</a:t>
+            </a:r>
+          </a:p>
+          <a:p>
+            <a:pPr>
+              <a:spcBef>
+                <a:spcPts val="300"/>
+              </a:spcBef>
+            </a:pPr>
+            <a:r>
+              <a:rPr sz="1300">
+                <a:solidFill>
+                  <a:srgbClr val="111111"/>
+                </a:solidFill>
+              </a:rPr>
+              <a:t>Available = what can currently be issued</a:t>
+            </a:r>
+          </a:p>
+          <a:p>
+            <a:pPr>
+              <a:spcBef>
+                <a:spcPts val="300"/>
+              </a:spcBef>
+            </a:pPr>
+            <a:r>
+              <a:rPr sz="1300">
+                <a:solidFill>
+                  <a:srgbClr val="111111"/>
+                </a:solidFill>
+              </a:rPr>
+              <a:t>Check this before creating an Issue Slip</a:t>
+            </a:r>
+          </a:p>
+          <a:p>
+            <a:pPr>
+              <a:spcBef>
+                <a:spcPts val="600"/>
+              </a:spcBef>
+            </a:pPr>
+            <a:r>
+              <a:rPr sz="1400" b="1">
+                <a:solidFill>
+                  <a:srgbClr val="0B4A8A"/>
+                </a:solidFill>
+              </a:rPr>
+              <a:t>Stock Items</a:t>
+            </a:r>
+          </a:p>
+          <a:p>
+            <a:pPr>
+              <a:spcBef>
+                <a:spcPts val="300"/>
+              </a:spcBef>
+            </a:pPr>
+            <a:r>
+              <a:rPr sz="1300">
+                <a:solidFill>
+                  <a:srgbClr val="111111"/>
+                </a:solidFill>
+              </a:rPr>
+              <a:t>Sidebar → Stores → Stock Items</a:t>
+            </a:r>
+          </a:p>
+          <a:p>
+            <a:pPr>
+              <a:spcBef>
+                <a:spcPts val="300"/>
+              </a:spcBef>
+            </a:pPr>
+            <a:r>
+              <a:rPr sz="1300">
+                <a:solidFill>
+                  <a:srgbClr val="111111"/>
+                </a:solidFill>
+              </a:rPr>
+              <a:t>Add or edit catalogue entries (name, unit, description, category)</a:t>
+            </a:r>
+          </a:p>
+          <a:p>
+            <a:pPr>
+              <a:spcBef>
+                <a:spcPts val="300"/>
+              </a:spcBef>
+            </a:pPr>
+            <a:r>
+              <a:rPr sz="1300">
+                <a:solidFill>
+                  <a:srgbClr val="111111"/>
+                </a:solidFill>
+              </a:rPr>
+              <a:t>Avoid duplicate descriptions — one record per item type</a:t>
+            </a:r>
+          </a:p>
+        </p:txBody>
+      </p:sp>
+    </p:spTree>
+  </p:cSld>
+  <p:clrMapOvr>
+    <a:masterClrMapping/>
+  </p:clrMapOvr>
+</p:sld>
+</file>
+
+<file path=ppt/slides/slide8.xml><?xml version="1.0" encoding="utf-8"?>
+<p:sld xmlns:a="http://schemas.openxmlformats.org/drawingml/2006/main" xmlns:p="http://schemas.openxmlformats.org/presentationml/2006/main" xmlns:r="http://schemas.openxmlformats.org/officeDocument/2006/relationships">
+  <p:cSld>
+    <p:spTree>
+      <p:nvGrpSpPr>
+        <p:cNvPr id="1" name=""/>
+        <p:cNvGrpSpPr/>
+        <p:nvPr/>
+      </p:nvGrpSpPr>
+      <p:grpSpPr/>
+      <p:sp>
+        <p:nvSpPr>
+          <p:cNvPr id="2" name="Rectangle 1"/>
+          <p:cNvSpPr/>
+          <p:nvPr/>
+        </p:nvSpPr>
+        <p:spPr>
+          <a:xfrm>
+            <a:off x="0" y="0"/>
+            <a:ext cx="12188952" cy="1051560"/>
+          </a:xfrm>
+          <a:prstGeom prst="rect">
+            <a:avLst/>
+          </a:prstGeom>
+          <a:solidFill>
+            <a:srgbClr val="0B4A8A"/>
+          </a:solidFill>
+          <a:ln>
+            <a:noFill/>
+          </a:ln>
+        </p:spPr>
+        <p:style>
+          <a:lnRef idx="1">
+            <a:schemeClr val="accent1"/>
+          </a:lnRef>
+          <a:fillRef idx="3">
+            <a:schemeClr val="accent1"/>
+          </a:fillRef>
+          <a:effectRef idx="2">
+            <a:schemeClr val="accent1"/>
+          </a:effectRef>
+          <a:fontRef idx="minor">
+            <a:schemeClr val="lt1"/>
+          </a:fontRef>
+        </p:style>
+        <p:txBody>
+          <a:bodyPr rtlCol="0" anchor="ctr"/>
+          <a:lstStyle/>
+          <a:p>
+            <a:pPr algn="ctr"/>
+          </a:p>
+        </p:txBody>
+      </p:sp>
+      <p:sp>
+        <p:nvSpPr>
+          <p:cNvPr id="3" name="TextBox 2"/>
+          <p:cNvSpPr txBox="1"/>
+          <p:nvPr/>
+        </p:nvSpPr>
+        <p:spPr>
+          <a:xfrm>
+            <a:off x="502920" y="274320"/>
+            <a:ext cx="11183112" cy="685800"/>
+          </a:xfrm>
+          <a:prstGeom prst="rect">
+            <a:avLst/>
+          </a:prstGeom>
+          <a:noFill/>
+        </p:spPr>
+        <p:txBody>
+          <a:bodyPr wrap="square">
+            <a:spAutoFit/>
+          </a:bodyPr>
+          <a:lstStyle/>
+          <a:p>
+            <a:pPr algn="l"/>
+            <a:r>
+              <a:rPr sz="2200" b="1" i="0">
+                <a:solidFill>
+                  <a:srgbClr val="FFFFFF"/>
+                </a:solidFill>
+              </a:rPr>
+              <a:t>Common Pitfalls &amp; Checklist</a:t>
+            </a:r>
+          </a:p>
+        </p:txBody>
+      </p:sp>
+      <p:sp>
+        <p:nvSpPr>
+          <p:cNvPr id="4" name="TextBox 3"/>
+          <p:cNvSpPr txBox="1"/>
+          <p:nvPr/>
+        </p:nvSpPr>
+        <p:spPr>
+          <a:xfrm>
+            <a:off x="502920" y="1188720"/>
+            <a:ext cx="11183112" cy="5440680"/>
+          </a:xfrm>
+          <a:prstGeom prst="rect">
+            <a:avLst/>
+          </a:prstGeom>
+          <a:noFill/>
+        </p:spPr>
+        <p:txBody>
+          <a:bodyPr wrap="square">
+            <a:spAutoFit/>
+          </a:bodyPr>
+          <a:lstStyle/>
+          <a:p>
+            <a:pPr>
+              <a:spcBef>
+                <a:spcPts val="600"/>
+              </a:spcBef>
+            </a:pPr>
+            <a:r>
+              <a:rPr sz="1400" b="1">
+                <a:solidFill>
+                  <a:srgbClr val="0B4A8A"/>
+                </a:solidFill>
+              </a:rPr>
+              <a:t>Before creating a GRN — check:</a:t>
+            </a:r>
+          </a:p>
+          <a:p>
+            <a:pPr>
+              <a:spcBef>
+                <a:spcPts val="300"/>
+              </a:spcBef>
+            </a:pPr>
+            <a:r>
+              <a:rPr sz="1300">
+                <a:solidFill>
+                  <a:srgbClr val="111111"/>
+                </a:solidFill>
+              </a:rPr>
+              <a:t>The Reference PR exists and is at status approved</a:t>
+            </a:r>
+          </a:p>
+          <a:p>
+            <a:pPr>
+              <a:spcBef>
+                <a:spcPts val="300"/>
+              </a:spcBef>
+            </a:pPr>
+            <a:r>
+              <a:rPr sz="1300">
+                <a:solidFill>
+                  <a:srgbClr val="111111"/>
+                </a:solidFill>
+              </a:rPr>
+              <a:t>Quantities on the delivery note match what Procurement ordered (raise any shortfall with Procurement)</a:t>
+            </a:r>
+          </a:p>
+          <a:p>
+            <a:pPr>
+              <a:spcBef>
+                <a:spcPts val="300"/>
+              </a:spcBef>
+            </a:pPr>
+            <a:r>
+              <a:rPr sz="1300">
+                <a:solidFill>
+                  <a:srgbClr val="111111"/>
+                </a:solidFill>
+              </a:rPr>
+              <a:t>The supplier on the delivery note matches the vendor on the PR</a:t>
+            </a:r>
+          </a:p>
+          <a:p>
+            <a:pPr>
+              <a:spcBef>
+                <a:spcPts val="300"/>
+              </a:spcBef>
+            </a:pPr>
+            <a:r>
+              <a:rPr sz="1300">
+                <a:solidFill>
+                  <a:srgbClr val="111111"/>
+                </a:solidFill>
+              </a:rPr>
+              <a:t>You have the physical delivery note or invoice to attach</a:t>
+            </a:r>
+          </a:p>
+          <a:p>
+            <a:pPr>
+              <a:spcBef>
+                <a:spcPts val="600"/>
+              </a:spcBef>
+            </a:pPr>
+            <a:r>
+              <a:rPr sz="1400" b="1">
+                <a:solidFill>
+                  <a:srgbClr val="0B4A8A"/>
+                </a:solidFill>
+              </a:rPr>
+              <a:t>Before creating an Issue Slip — check:</a:t>
+            </a:r>
+          </a:p>
+          <a:p>
+            <a:pPr>
+              <a:spcBef>
+                <a:spcPts val="300"/>
+              </a:spcBef>
+            </a:pPr>
+            <a:r>
+              <a:rPr sz="1300">
+                <a:solidFill>
+                  <a:srgbClr val="111111"/>
+                </a:solidFill>
+              </a:rPr>
+              <a:t>The GRN is approved (not still pending_approval)</a:t>
+            </a:r>
+          </a:p>
+          <a:p>
+            <a:pPr>
+              <a:spcBef>
+                <a:spcPts val="300"/>
+              </a:spcBef>
+            </a:pPr>
+            <a:r>
+              <a:rPr sz="1300">
+                <a:solidFill>
+                  <a:srgbClr val="111111"/>
+                </a:solidFill>
+              </a:rPr>
+              <a:t>There is enough available stock in the Register</a:t>
+            </a:r>
+          </a:p>
+          <a:p>
+            <a:pPr>
+              <a:spcBef>
+                <a:spcPts val="300"/>
+              </a:spcBef>
+            </a:pPr>
+            <a:r>
+              <a:rPr sz="1300">
+                <a:solidFill>
+                  <a:srgbClr val="111111"/>
+                </a:solidFill>
+              </a:rPr>
+              <a:t>The recipient department is correct — stock deductions cannot be reversed</a:t>
+            </a:r>
+          </a:p>
+          <a:p>
+            <a:pPr>
+              <a:spcBef>
+                <a:spcPts val="600"/>
+              </a:spcBef>
+            </a:pPr>
+            <a:r>
+              <a:rPr sz="1400" b="1">
+                <a:solidFill>
+                  <a:srgbClr val="0B4A8A"/>
+                </a:solidFill>
+              </a:rPr>
+              <a:t>Common mistakes:</a:t>
+            </a:r>
+          </a:p>
+          <a:p>
+            <a:pPr>
+              <a:spcBef>
+                <a:spcPts val="300"/>
+              </a:spcBef>
+            </a:pPr>
+            <a:r>
+              <a:rPr sz="1300">
+                <a:solidFill>
+                  <a:srgbClr val="111111"/>
+                </a:solidFill>
+              </a:rPr>
+              <a:t>GRN linked to wrong PR → the stock register can't reconcile correctly</a:t>
+            </a:r>
+          </a:p>
+          <a:p>
+            <a:pPr>
+              <a:spcBef>
+                <a:spcPts val="300"/>
+              </a:spcBef>
+            </a:pPr>
+            <a:r>
+              <a:rPr sz="1300">
+                <a:solidFill>
+                  <a:srgbClr val="111111"/>
+                </a:solidFill>
+              </a:rPr>
+              <a:t>Issue Slip created before GRN is Finance-approved → submission blocked</a:t>
+            </a:r>
+          </a:p>
+          <a:p>
+            <a:pPr>
+              <a:spcBef>
+                <a:spcPts val="300"/>
+              </a:spcBef>
+            </a:pPr>
+            <a:r>
+              <a:rPr sz="1300">
+                <a:solidFill>
+                  <a:srgbClr val="111111"/>
+                </a:solidFill>
+              </a:rPr>
+              <a:t>Over-issuing by entering wrong quantities → the system prevents this but double-check</a:t>
+            </a:r>
+          </a:p>
+        </p:txBody>
+      </p:sp>
+    </p:spTree>
+  </p:cSld>
+  <p:clrMapOvr>
+    <a:masterClrMapping/>
+  </p:clrMapOvr>
+</p:sld>
+</file>
+
+<file path=ppt/slides/slide9.xml><?xml version="1.0" encoding="utf-8"?>
 <p:sld xmlns:a="http://schemas.openxmlformats.org/drawingml/2006/main" xmlns:p="http://schemas.openxmlformats.org/presentationml/2006/main" xmlns:r="http://schemas.openxmlformats.org/officeDocument/2006/relationships">
   <p:cSld>
     <p:spTree>

</xml_diff>